<commit_message>
P5·P6 상품명 마스킹: KODEX → *****
- 5·6페이지 본문·각주 텍스트 및 차트 범례의 KODEX를 *****로 교체 (구체 상품명 표기에 따른 문제 소지 방지)
- 데이터 조회용 종목명은 스크립트 내부에만 유지, 표시 라벨만 마스킹

Co-Authored-By: Claude Fable 5 <noreply@anthropic.com>
</commit_message>
<xml_diff>
--- a/제안서/Tech_TOP10_스마트액티브레버리지15_v1_20260812.pptx
+++ b/제안서/Tech_TOP10_스마트액티브레버리지15_v1_20260812.pptx
@@ -24019,9 +24019,87 @@
           </a:p>
         </p:txBody>
       </p:sp>
+      <p:sp>
+        <p:nvSpPr>
+          <p:cNvPr id="6" name="TextBox 5"/>
+          <p:cNvSpPr txBox="1"/>
+          <p:nvPr/>
+        </p:nvSpPr>
+        <p:spPr>
+          <a:xfrm>
+            <a:off x="731520" y="5440680"/>
+            <a:ext cx="8351520" cy="457200"/>
+          </a:xfrm>
+          <a:prstGeom prst="rect">
+            <a:avLst/>
+          </a:prstGeom>
+          <a:noFill/>
+        </p:spPr>
+        <p:txBody>
+          <a:bodyPr wrap="square">
+            <a:spAutoFit/>
+          </a:bodyPr>
+          <a:lstStyle/>
+          <a:p>
+            <a:pPr>
+              <a:lnSpc>
+                <a:spcPct val="115000"/>
+              </a:lnSpc>
+            </a:pPr>
+            <a:r>
+              <a:rPr sz="1400" b="1">
+                <a:solidFill>
+                  <a:srgbClr val="E8720C"/>
+                </a:solidFill>
+                <a:latin typeface="KoPub돋움체_Pro Bold"/>
+              </a:rPr>
+              <a:t>방향이 아니라 '경로'가 성과를 결정합니다 — 왕복 구간에서는 지수가 제자리여도 손실이 쌓입니다.</a:t>
+            </a:r>
+          </a:p>
+        </p:txBody>
+      </p:sp>
+      <p:sp>
+        <p:nvSpPr>
+          <p:cNvPr id="7" name="TextBox 6"/>
+          <p:cNvSpPr txBox="1"/>
+          <p:nvPr/>
+        </p:nvSpPr>
+        <p:spPr>
+          <a:xfrm>
+            <a:off x="502920" y="6291072"/>
+            <a:ext cx="8900160" cy="365760"/>
+          </a:xfrm>
+          <a:prstGeom prst="rect">
+            <a:avLst/>
+          </a:prstGeom>
+          <a:noFill/>
+        </p:spPr>
+        <p:txBody>
+          <a:bodyPr wrap="square">
+            <a:spAutoFit/>
+          </a:bodyPr>
+          <a:lstStyle/>
+          <a:p>
+            <a:pPr>
+              <a:lnSpc>
+                <a:spcPct val="115000"/>
+              </a:lnSpc>
+            </a:pPr>
+            <a:r>
+              <a:rPr sz="800" b="0">
+                <a:solidFill>
+                  <a:srgbClr val="84888B"/>
+                </a:solidFill>
+                <a:latin typeface="KoPub돋움체_Pro Medium"/>
+              </a:rPr>
+              <a:t>※ ***** 200·***** 레버리지 수정주가 실측 (제자리 사례 2026.02.26~04.16) · '시장 2배 후 제자리 = 0'과 '하루 +10% 후 제자리 = -1.8%'는 2배 레버리지 산술 · 데이터: ETF데이터</a:t>
+            </a:r>
+          </a:p>
+        </p:txBody>
+      </p:sp>
       <p:pic>
         <p:nvPicPr>
-          <p:cNvPr id="4" name="Picture 3" descr="image.png"/>
+          <p:cNvPr id="8" name="Picture 7" descr="image.png"/>
           <p:cNvPicPr>
             <a:picLocks noChangeAspect="1"/>
           </p:cNvPicPr>
@@ -24045,14 +24123,14 @@
       </p:pic>
       <p:pic>
         <p:nvPicPr>
-          <p:cNvPr id="5" name="Picture 4" descr="image.png"/>
+          <p:cNvPr id="9" name="Picture 8" descr="lev15_k200flat.png"/>
           <p:cNvPicPr>
             <a:picLocks noChangeAspect="1"/>
           </p:cNvPicPr>
           <p:nvPr/>
         </p:nvPicPr>
         <p:blipFill>
-          <a:blip r:embed="rId7"/>
+          <a:blip r:embed="rId8"/>
           <a:stretch>
             <a:fillRect/>
           </a:stretch>
@@ -24067,84 +24145,6 @@
           </a:prstGeom>
         </p:spPr>
       </p:pic>
-      <p:sp>
-        <p:nvSpPr>
-          <p:cNvPr id="6" name="TextBox 5"/>
-          <p:cNvSpPr txBox="1"/>
-          <p:nvPr/>
-        </p:nvSpPr>
-        <p:spPr>
-          <a:xfrm>
-            <a:off x="731520" y="5440680"/>
-            <a:ext cx="8351520" cy="457200"/>
-          </a:xfrm>
-          <a:prstGeom prst="rect">
-            <a:avLst/>
-          </a:prstGeom>
-          <a:noFill/>
-        </p:spPr>
-        <p:txBody>
-          <a:bodyPr wrap="square">
-            <a:spAutoFit/>
-          </a:bodyPr>
-          <a:lstStyle/>
-          <a:p>
-            <a:pPr>
-              <a:lnSpc>
-                <a:spcPct val="115000"/>
-              </a:lnSpc>
-            </a:pPr>
-            <a:r>
-              <a:rPr sz="1400" b="1">
-                <a:solidFill>
-                  <a:srgbClr val="E8720C"/>
-                </a:solidFill>
-                <a:latin typeface="KoPub돋움체_Pro Bold"/>
-              </a:rPr>
-              <a:t>방향이 아니라 '경로'가 성과를 결정합니다 — 왕복 구간에서는 지수가 제자리여도 손실이 쌓입니다.</a:t>
-            </a:r>
-          </a:p>
-        </p:txBody>
-      </p:sp>
-      <p:sp>
-        <p:nvSpPr>
-          <p:cNvPr id="7" name="TextBox 6"/>
-          <p:cNvSpPr txBox="1"/>
-          <p:nvPr/>
-        </p:nvSpPr>
-        <p:spPr>
-          <a:xfrm>
-            <a:off x="502920" y="6291072"/>
-            <a:ext cx="8900160" cy="365760"/>
-          </a:xfrm>
-          <a:prstGeom prst="rect">
-            <a:avLst/>
-          </a:prstGeom>
-          <a:noFill/>
-        </p:spPr>
-        <p:txBody>
-          <a:bodyPr wrap="square">
-            <a:spAutoFit/>
-          </a:bodyPr>
-          <a:lstStyle/>
-          <a:p>
-            <a:pPr>
-              <a:lnSpc>
-                <a:spcPct val="115000"/>
-              </a:lnSpc>
-            </a:pPr>
-            <a:r>
-              <a:rPr sz="800" b="0">
-                <a:solidFill>
-                  <a:srgbClr val="84888B"/>
-                </a:solidFill>
-                <a:latin typeface="KoPub돋움체_Pro Medium"/>
-              </a:rPr>
-              <a:t>※ KODEX 200·KODEX 레버리지 수정주가 실측 (제자리 사례 2026.02.26~04.16) · '시장 2배 후 제자리 = 0'과 '하루 +10% 후 제자리 = -1.8%'는 2배 레버리지 산술 · 데이터: ETF데이터</a:t>
-            </a:r>
-          </a:p>
-        </p:txBody>
-      </p:sp>
     </p:spTree>
     <p:extLst>
       <p:ext uri="{BB962C8B-B14F-4D97-AF65-F5344CB8AC3E}">
@@ -24253,21 +24253,99 @@
                   <a:srgbClr val="222222"/>
                 </a:solidFill>
               </a:rPr>
-              <a:t>① KOSPI200이 4년 5개월 걸려 제자리로 왔을 때 레버리지는 -27.1%  ② KODEX 하이닉스 레버리지는 출시 6주 뒤 주가 보합(-1.9%)인데 -20.3%  ③ 주가 제자리(+0.3%) 왕복 5주 만에 -15.2%.</a:t>
+              <a:t>① KOSPI200이 4년 5개월 걸려 제자리로 왔을 때 레버리지는 -27.1%  ② ***** 하이닉스 레버리지는 출시 6주 뒤 주가 보합(-1.9%)인데 -20.3%  ③ 주가 제자리(+0.3%) 왕복 5주 만에 -15.2%.</a:t>
+            </a:r>
+          </a:p>
+        </p:txBody>
+      </p:sp>
+      <p:sp>
+        <p:nvSpPr>
+          <p:cNvPr id="7" name="TextBox 6"/>
+          <p:cNvSpPr txBox="1"/>
+          <p:nvPr/>
+        </p:nvSpPr>
+        <p:spPr>
+          <a:xfrm>
+            <a:off x="731520" y="5440680"/>
+            <a:ext cx="8351520" cy="457200"/>
+          </a:xfrm>
+          <a:prstGeom prst="rect">
+            <a:avLst/>
+          </a:prstGeom>
+          <a:noFill/>
+        </p:spPr>
+        <p:txBody>
+          <a:bodyPr wrap="square">
+            <a:spAutoFit/>
+          </a:bodyPr>
+          <a:lstStyle/>
+          <a:p>
+            <a:pPr>
+              <a:lnSpc>
+                <a:spcPct val="115000"/>
+              </a:lnSpc>
+            </a:pPr>
+            <a:r>
+              <a:rPr sz="1400" b="1">
+                <a:solidFill>
+                  <a:srgbClr val="E8720C"/>
+                </a:solidFill>
+                <a:latin typeface="KoPub돋움체_Pro Bold"/>
+              </a:rPr>
+              <a:t>잠식은 '왕복'에 청구되는 요금입니다 — 기간이 길수록, 변동이 클수록 요금은 커집니다.</a:t>
+            </a:r>
+          </a:p>
+        </p:txBody>
+      </p:sp>
+      <p:sp>
+        <p:nvSpPr>
+          <p:cNvPr id="8" name="TextBox 7"/>
+          <p:cNvSpPr txBox="1"/>
+          <p:nvPr/>
+        </p:nvSpPr>
+        <p:spPr>
+          <a:xfrm>
+            <a:off x="502920" y="6291072"/>
+            <a:ext cx="8900160" cy="365760"/>
+          </a:xfrm>
+          <a:prstGeom prst="rect">
+            <a:avLst/>
+          </a:prstGeom>
+          <a:noFill/>
+        </p:spPr>
+        <p:txBody>
+          <a:bodyPr wrap="square">
+            <a:spAutoFit/>
+          </a:bodyPr>
+          <a:lstStyle/>
+          <a:p>
+            <a:pPr>
+              <a:lnSpc>
+                <a:spcPct val="115000"/>
+              </a:lnSpc>
+            </a:pPr>
+            <a:r>
+              <a:rPr sz="800" b="0">
+                <a:solidFill>
+                  <a:srgbClr val="84888B"/>
+                </a:solidFill>
+                <a:latin typeface="KoPub돋움체_Pro Medium"/>
+              </a:rPr>
+              <a:t>※ 전 구간 실제값 (수정주가 기준) · ***** 200/***** 레버리지·***** SK하이닉스단일종목레버리지(2026.05.27 상장): ETF데이터 · SK하이닉스 주가: DataGuide (2026.08.14 기준) · 상기 자료는 이해를 돕기 위한 예시입니다.</a:t>
             </a:r>
           </a:p>
         </p:txBody>
       </p:sp>
       <p:pic>
         <p:nvPicPr>
-          <p:cNvPr id="4" name="Picture 3" descr="image.png"/>
+          <p:cNvPr id="9" name="Picture 8" descr="lev15_long_k200.png"/>
           <p:cNvPicPr>
             <a:picLocks noChangeAspect="1"/>
           </p:cNvPicPr>
           <p:nvPr/>
         </p:nvPicPr>
         <p:blipFill>
-          <a:blip r:embed="rId7"/>
+          <a:blip r:embed="rId10"/>
           <a:stretch>
             <a:fillRect/>
           </a:stretch>
@@ -24284,14 +24362,14 @@
       </p:pic>
       <p:pic>
         <p:nvPicPr>
-          <p:cNvPr id="5" name="Picture 4" descr="image.png"/>
+          <p:cNvPr id="10" name="Picture 9" descr="lev15_hynix_a.png"/>
           <p:cNvPicPr>
             <a:picLocks noChangeAspect="1"/>
           </p:cNvPicPr>
           <p:nvPr/>
         </p:nvPicPr>
         <p:blipFill>
-          <a:blip r:embed="rId8"/>
+          <a:blip r:embed="rId11"/>
           <a:stretch>
             <a:fillRect/>
           </a:stretch>
@@ -24308,14 +24386,14 @@
       </p:pic>
       <p:pic>
         <p:nvPicPr>
-          <p:cNvPr id="6" name="Picture 5" descr="image.png"/>
+          <p:cNvPr id="11" name="Picture 10" descr="lev15_hynix_b.png"/>
           <p:cNvPicPr>
             <a:picLocks noChangeAspect="1"/>
           </p:cNvPicPr>
           <p:nvPr/>
         </p:nvPicPr>
         <p:blipFill>
-          <a:blip r:embed="rId9"/>
+          <a:blip r:embed="rId12"/>
           <a:stretch>
             <a:fillRect/>
           </a:stretch>
@@ -24330,84 +24408,6 @@
           </a:prstGeom>
         </p:spPr>
       </p:pic>
-      <p:sp>
-        <p:nvSpPr>
-          <p:cNvPr id="7" name="TextBox 6"/>
-          <p:cNvSpPr txBox="1"/>
-          <p:nvPr/>
-        </p:nvSpPr>
-        <p:spPr>
-          <a:xfrm>
-            <a:off x="731520" y="5440680"/>
-            <a:ext cx="8351520" cy="457200"/>
-          </a:xfrm>
-          <a:prstGeom prst="rect">
-            <a:avLst/>
-          </a:prstGeom>
-          <a:noFill/>
-        </p:spPr>
-        <p:txBody>
-          <a:bodyPr wrap="square">
-            <a:spAutoFit/>
-          </a:bodyPr>
-          <a:lstStyle/>
-          <a:p>
-            <a:pPr>
-              <a:lnSpc>
-                <a:spcPct val="115000"/>
-              </a:lnSpc>
-            </a:pPr>
-            <a:r>
-              <a:rPr sz="1400" b="1">
-                <a:solidFill>
-                  <a:srgbClr val="E8720C"/>
-                </a:solidFill>
-                <a:latin typeface="KoPub돋움체_Pro Bold"/>
-              </a:rPr>
-              <a:t>잠식은 '왕복'에 청구되는 요금입니다 — 기간이 길수록, 변동이 클수록 요금은 커집니다.</a:t>
-            </a:r>
-          </a:p>
-        </p:txBody>
-      </p:sp>
-      <p:sp>
-        <p:nvSpPr>
-          <p:cNvPr id="8" name="TextBox 7"/>
-          <p:cNvSpPr txBox="1"/>
-          <p:nvPr/>
-        </p:nvSpPr>
-        <p:spPr>
-          <a:xfrm>
-            <a:off x="502920" y="6291072"/>
-            <a:ext cx="8900160" cy="365760"/>
-          </a:xfrm>
-          <a:prstGeom prst="rect">
-            <a:avLst/>
-          </a:prstGeom>
-          <a:noFill/>
-        </p:spPr>
-        <p:txBody>
-          <a:bodyPr wrap="square">
-            <a:spAutoFit/>
-          </a:bodyPr>
-          <a:lstStyle/>
-          <a:p>
-            <a:pPr>
-              <a:lnSpc>
-                <a:spcPct val="115000"/>
-              </a:lnSpc>
-            </a:pPr>
-            <a:r>
-              <a:rPr sz="800" b="0">
-                <a:solidFill>
-                  <a:srgbClr val="84888B"/>
-                </a:solidFill>
-                <a:latin typeface="KoPub돋움체_Pro Medium"/>
-              </a:rPr>
-              <a:t>※ 전 구간 실제값 (수정주가 기준) · KODEX 200/KODEX 레버리지·KODEX SK하이닉스단일종목레버리지(2026.05.27 상장): ETF데이터 · SK하이닉스 주가: DataGuide (2026.08.14 기준) · 상기 자료는 이해를 돕기 위한 예시입니다.</a:t>
-            </a:r>
-          </a:p>
-        </p:txBody>
-      </p:sp>
     </p:spTree>
     <p:extLst>
       <p:ext uri="{BB962C8B-B14F-4D97-AF65-F5344CB8AC3E}">

</xml_diff>